<commit_message>
breadboard for Arduino nano added.
</commit_message>
<xml_diff>
--- a/photos/model_guide.pptx
+++ b/photos/model_guide.pptx
@@ -11,6 +11,7 @@
     <p:sldId id="256" r:id="rId5"/>
     <p:sldId id="260" r:id="rId6"/>
     <p:sldId id="261" r:id="rId7"/>
+    <p:sldId id="262" r:id="rId8"/>
   </p:sldIdLst>
   <p:sldSz cx="12192000" cy="6858000"/>
   <p:notesSz cx="6858000" cy="9144000"/>
@@ -109,6 +110,11 @@
       </a:defRPr>
     </a:lvl9pPr>
   </p:defaultTextStyle>
+  <p:extLst>
+    <p:ext uri="{EFAFB233-063F-42B5-8137-9DF3F51BA10A}">
+      <p15:sldGuideLst xmlns:p15="http://schemas.microsoft.com/office/powerpoint/2012/main"/>
+    </p:ext>
+  </p:extLst>
 </p:presentation>
 </file>
 
@@ -259,7 +265,7 @@
           <a:p>
             <a:fld id="{D6A17A5A-5076-A449-98C9-5F4D0ED8A07E}" type="datetimeFigureOut">
               <a:rPr lang="de-DE" smtClean="0"/>
-              <a:t>27.01.26</a:t>
+              <a:t>28.01.26</a:t>
             </a:fld>
             <a:endParaRPr lang="de-DE"/>
           </a:p>
@@ -457,7 +463,7 @@
           <a:p>
             <a:fld id="{D6A17A5A-5076-A449-98C9-5F4D0ED8A07E}" type="datetimeFigureOut">
               <a:rPr lang="de-DE" smtClean="0"/>
-              <a:t>27.01.26</a:t>
+              <a:t>28.01.26</a:t>
             </a:fld>
             <a:endParaRPr lang="de-DE"/>
           </a:p>
@@ -665,7 +671,7 @@
           <a:p>
             <a:fld id="{D6A17A5A-5076-A449-98C9-5F4D0ED8A07E}" type="datetimeFigureOut">
               <a:rPr lang="de-DE" smtClean="0"/>
-              <a:t>27.01.26</a:t>
+              <a:t>28.01.26</a:t>
             </a:fld>
             <a:endParaRPr lang="de-DE"/>
           </a:p>
@@ -863,7 +869,7 @@
           <a:p>
             <a:fld id="{D6A17A5A-5076-A449-98C9-5F4D0ED8A07E}" type="datetimeFigureOut">
               <a:rPr lang="de-DE" smtClean="0"/>
-              <a:t>27.01.26</a:t>
+              <a:t>28.01.26</a:t>
             </a:fld>
             <a:endParaRPr lang="de-DE"/>
           </a:p>
@@ -1138,7 +1144,7 @@
           <a:p>
             <a:fld id="{D6A17A5A-5076-A449-98C9-5F4D0ED8A07E}" type="datetimeFigureOut">
               <a:rPr lang="de-DE" smtClean="0"/>
-              <a:t>27.01.26</a:t>
+              <a:t>28.01.26</a:t>
             </a:fld>
             <a:endParaRPr lang="de-DE"/>
           </a:p>
@@ -1403,7 +1409,7 @@
           <a:p>
             <a:fld id="{D6A17A5A-5076-A449-98C9-5F4D0ED8A07E}" type="datetimeFigureOut">
               <a:rPr lang="de-DE" smtClean="0"/>
-              <a:t>27.01.26</a:t>
+              <a:t>28.01.26</a:t>
             </a:fld>
             <a:endParaRPr lang="de-DE"/>
           </a:p>
@@ -1815,7 +1821,7 @@
           <a:p>
             <a:fld id="{D6A17A5A-5076-A449-98C9-5F4D0ED8A07E}" type="datetimeFigureOut">
               <a:rPr lang="de-DE" smtClean="0"/>
-              <a:t>27.01.26</a:t>
+              <a:t>28.01.26</a:t>
             </a:fld>
             <a:endParaRPr lang="de-DE"/>
           </a:p>
@@ -1956,7 +1962,7 @@
           <a:p>
             <a:fld id="{D6A17A5A-5076-A449-98C9-5F4D0ED8A07E}" type="datetimeFigureOut">
               <a:rPr lang="de-DE" smtClean="0"/>
-              <a:t>27.01.26</a:t>
+              <a:t>28.01.26</a:t>
             </a:fld>
             <a:endParaRPr lang="de-DE"/>
           </a:p>
@@ -2069,7 +2075,7 @@
           <a:p>
             <a:fld id="{D6A17A5A-5076-A449-98C9-5F4D0ED8A07E}" type="datetimeFigureOut">
               <a:rPr lang="de-DE" smtClean="0"/>
-              <a:t>27.01.26</a:t>
+              <a:t>28.01.26</a:t>
             </a:fld>
             <a:endParaRPr lang="de-DE"/>
           </a:p>
@@ -2380,7 +2386,7 @@
           <a:p>
             <a:fld id="{D6A17A5A-5076-A449-98C9-5F4D0ED8A07E}" type="datetimeFigureOut">
               <a:rPr lang="de-DE" smtClean="0"/>
-              <a:t>27.01.26</a:t>
+              <a:t>28.01.26</a:t>
             </a:fld>
             <a:endParaRPr lang="de-DE"/>
           </a:p>
@@ -2668,7 +2674,7 @@
           <a:p>
             <a:fld id="{D6A17A5A-5076-A449-98C9-5F4D0ED8A07E}" type="datetimeFigureOut">
               <a:rPr lang="de-DE" smtClean="0"/>
-              <a:t>27.01.26</a:t>
+              <a:t>28.01.26</a:t>
             </a:fld>
             <a:endParaRPr lang="de-DE"/>
           </a:p>
@@ -2909,7 +2915,7 @@
           <a:p>
             <a:fld id="{D6A17A5A-5076-A449-98C9-5F4D0ED8A07E}" type="datetimeFigureOut">
               <a:rPr lang="de-DE" smtClean="0"/>
-              <a:t>27.01.26</a:t>
+              <a:t>28.01.26</a:t>
             </a:fld>
             <a:endParaRPr lang="de-DE"/>
           </a:p>
@@ -6242,6 +6248,473 @@
 </p:sld>
 </file>
 
+<file path=ppt/slides/slide7.xml><?xml version="1.0" encoding="utf-8"?>
+<p:sld xmlns:a="http://schemas.openxmlformats.org/drawingml/2006/main" xmlns:r="http://schemas.openxmlformats.org/officeDocument/2006/relationships" xmlns:p="http://schemas.openxmlformats.org/presentationml/2006/main">
+  <p:cSld>
+    <p:spTree>
+      <p:nvGrpSpPr>
+        <p:cNvPr id="1" name=""/>
+        <p:cNvGrpSpPr/>
+        <p:nvPr/>
+      </p:nvGrpSpPr>
+      <p:grpSpPr>
+        <a:xfrm>
+          <a:off x="0" y="0"/>
+          <a:ext cx="0" cy="0"/>
+          <a:chOff x="0" y="0"/>
+          <a:chExt cx="0" cy="0"/>
+        </a:xfrm>
+      </p:grpSpPr>
+      <p:pic>
+        <p:nvPicPr>
+          <p:cNvPr id="4" name="Grafik 3">
+            <a:extLst>
+              <a:ext uri="{FF2B5EF4-FFF2-40B4-BE49-F238E27FC236}">
+                <a16:creationId xmlns:a16="http://schemas.microsoft.com/office/drawing/2014/main" id="{6B12A764-4C0F-9E49-A527-ECFB0121D747}"/>
+              </a:ext>
+            </a:extLst>
+          </p:cNvPr>
+          <p:cNvPicPr>
+            <a:picLocks noChangeAspect="1"/>
+          </p:cNvPicPr>
+          <p:nvPr/>
+        </p:nvPicPr>
+        <p:blipFill>
+          <a:blip r:embed="rId2"/>
+          <a:stretch>
+            <a:fillRect/>
+          </a:stretch>
+        </p:blipFill>
+        <p:spPr>
+          <a:xfrm>
+            <a:off x="1596000" y="1587266"/>
+            <a:ext cx="9000000" cy="3683467"/>
+          </a:xfrm>
+          <a:prstGeom prst="rect">
+            <a:avLst/>
+          </a:prstGeom>
+        </p:spPr>
+      </p:pic>
+      <p:cxnSp>
+        <p:nvCxnSpPr>
+          <p:cNvPr id="5" name="Gerade Verbindung 4">
+            <a:extLst>
+              <a:ext uri="{FF2B5EF4-FFF2-40B4-BE49-F238E27FC236}">
+                <a16:creationId xmlns:a16="http://schemas.microsoft.com/office/drawing/2014/main" id="{43FB2BAE-46BB-E7F1-4BA2-EAACEB03E7FC}"/>
+              </a:ext>
+            </a:extLst>
+          </p:cNvPr>
+          <p:cNvCxnSpPr>
+            <a:cxnSpLocks/>
+          </p:cNvCxnSpPr>
+          <p:nvPr/>
+        </p:nvCxnSpPr>
+        <p:spPr>
+          <a:xfrm>
+            <a:off x="10289176" y="3013267"/>
+            <a:ext cx="1097280" cy="0"/>
+          </a:xfrm>
+          <a:prstGeom prst="line">
+            <a:avLst/>
+          </a:prstGeom>
+          <a:ln w="50800">
+            <a:solidFill>
+              <a:srgbClr val="FF0000"/>
+            </a:solidFill>
+          </a:ln>
+        </p:spPr>
+        <p:style>
+          <a:lnRef idx="2">
+            <a:schemeClr val="accent1"/>
+          </a:lnRef>
+          <a:fillRef idx="0">
+            <a:schemeClr val="accent1"/>
+          </a:fillRef>
+          <a:effectRef idx="1">
+            <a:schemeClr val="accent1"/>
+          </a:effectRef>
+          <a:fontRef idx="minor">
+            <a:schemeClr val="tx1"/>
+          </a:fontRef>
+        </p:style>
+      </p:cxnSp>
+      <p:cxnSp>
+        <p:nvCxnSpPr>
+          <p:cNvPr id="6" name="Gerade Verbindung 5">
+            <a:extLst>
+              <a:ext uri="{FF2B5EF4-FFF2-40B4-BE49-F238E27FC236}">
+                <a16:creationId xmlns:a16="http://schemas.microsoft.com/office/drawing/2014/main" id="{028A33B5-37B7-A989-0C76-19D4BA5284C3}"/>
+              </a:ext>
+            </a:extLst>
+          </p:cNvPr>
+          <p:cNvCxnSpPr>
+            <a:cxnSpLocks/>
+          </p:cNvCxnSpPr>
+          <p:nvPr/>
+        </p:nvCxnSpPr>
+        <p:spPr>
+          <a:xfrm>
+            <a:off x="10289176" y="3828181"/>
+            <a:ext cx="1097280" cy="0"/>
+          </a:xfrm>
+          <a:prstGeom prst="line">
+            <a:avLst/>
+          </a:prstGeom>
+          <a:ln w="50800">
+            <a:solidFill>
+              <a:srgbClr val="FF0000"/>
+            </a:solidFill>
+          </a:ln>
+        </p:spPr>
+        <p:style>
+          <a:lnRef idx="2">
+            <a:schemeClr val="accent1"/>
+          </a:lnRef>
+          <a:fillRef idx="0">
+            <a:schemeClr val="accent1"/>
+          </a:fillRef>
+          <a:effectRef idx="1">
+            <a:schemeClr val="accent1"/>
+          </a:effectRef>
+          <a:fontRef idx="minor">
+            <a:schemeClr val="tx1"/>
+          </a:fontRef>
+        </p:style>
+      </p:cxnSp>
+      <p:cxnSp>
+        <p:nvCxnSpPr>
+          <p:cNvPr id="7" name="Gerade Verbindung 6">
+            <a:extLst>
+              <a:ext uri="{FF2B5EF4-FFF2-40B4-BE49-F238E27FC236}">
+                <a16:creationId xmlns:a16="http://schemas.microsoft.com/office/drawing/2014/main" id="{EF29658E-C19D-B36C-01AD-8E8355B54D89}"/>
+              </a:ext>
+            </a:extLst>
+          </p:cNvPr>
+          <p:cNvCxnSpPr>
+            <a:cxnSpLocks/>
+          </p:cNvCxnSpPr>
+          <p:nvPr/>
+        </p:nvCxnSpPr>
+        <p:spPr>
+          <a:xfrm flipV="1">
+            <a:off x="10596000" y="3013267"/>
+            <a:ext cx="0" cy="814914"/>
+          </a:xfrm>
+          <a:prstGeom prst="line">
+            <a:avLst/>
+          </a:prstGeom>
+          <a:ln w="50800">
+            <a:solidFill>
+              <a:srgbClr val="FF0000"/>
+            </a:solidFill>
+            <a:headEnd type="stealth"/>
+            <a:tailEnd type="stealth"/>
+          </a:ln>
+        </p:spPr>
+        <p:style>
+          <a:lnRef idx="2">
+            <a:schemeClr val="accent1"/>
+          </a:lnRef>
+          <a:fillRef idx="0">
+            <a:schemeClr val="accent1"/>
+          </a:fillRef>
+          <a:effectRef idx="1">
+            <a:schemeClr val="accent1"/>
+          </a:effectRef>
+          <a:fontRef idx="minor">
+            <a:schemeClr val="tx1"/>
+          </a:fontRef>
+        </p:style>
+      </p:cxnSp>
+      <p:sp>
+        <p:nvSpPr>
+          <p:cNvPr id="8" name="Textfeld 7">
+            <a:extLst>
+              <a:ext uri="{FF2B5EF4-FFF2-40B4-BE49-F238E27FC236}">
+                <a16:creationId xmlns:a16="http://schemas.microsoft.com/office/drawing/2014/main" id="{8FCBE31F-6CDE-C96D-87D1-D8AF54BE0929}"/>
+              </a:ext>
+            </a:extLst>
+          </p:cNvPr>
+          <p:cNvSpPr txBox="1"/>
+          <p:nvPr/>
+        </p:nvSpPr>
+        <p:spPr>
+          <a:xfrm>
+            <a:off x="10654698" y="3089651"/>
+            <a:ext cx="1374094" cy="646331"/>
+          </a:xfrm>
+          <a:prstGeom prst="rect">
+            <a:avLst/>
+          </a:prstGeom>
+          <a:noFill/>
+        </p:spPr>
+        <p:txBody>
+          <a:bodyPr wrap="none" rtlCol="0">
+            <a:spAutoFit/>
+          </a:bodyPr>
+          <a:lstStyle/>
+          <a:p>
+            <a:r>
+              <a:rPr lang="de-DE" b="1" dirty="0">
+                <a:solidFill>
+                  <a:srgbClr val="FF0000"/>
+                </a:solidFill>
+              </a:rPr>
+              <a:t>600 </a:t>
+            </a:r>
+            <a:r>
+              <a:rPr lang="de-DE" b="1" dirty="0" err="1">
+                <a:solidFill>
+                  <a:srgbClr val="FF0000"/>
+                </a:solidFill>
+              </a:rPr>
+              <a:t>mil</a:t>
+            </a:r>
+            <a:br>
+              <a:rPr lang="de-DE" b="1" dirty="0">
+                <a:solidFill>
+                  <a:srgbClr val="FF0000"/>
+                </a:solidFill>
+              </a:rPr>
+            </a:br>
+            <a:r>
+              <a:rPr lang="de-DE" b="1" dirty="0">
+                <a:solidFill>
+                  <a:srgbClr val="FF0000"/>
+                </a:solidFill>
+              </a:rPr>
+              <a:t>= 15.24 mm</a:t>
+            </a:r>
+          </a:p>
+        </p:txBody>
+      </p:sp>
+      <p:sp>
+        <p:nvSpPr>
+          <p:cNvPr id="10" name="Textfeld 9">
+            <a:extLst>
+              <a:ext uri="{FF2B5EF4-FFF2-40B4-BE49-F238E27FC236}">
+                <a16:creationId xmlns:a16="http://schemas.microsoft.com/office/drawing/2014/main" id="{D9E0F69E-1329-B824-4A66-C7FEBBD0641D}"/>
+              </a:ext>
+            </a:extLst>
+          </p:cNvPr>
+          <p:cNvSpPr txBox="1"/>
+          <p:nvPr/>
+        </p:nvSpPr>
+        <p:spPr>
+          <a:xfrm>
+            <a:off x="3034104" y="600075"/>
+            <a:ext cx="6123792" cy="584775"/>
+          </a:xfrm>
+          <a:prstGeom prst="rect">
+            <a:avLst/>
+          </a:prstGeom>
+          <a:noFill/>
+        </p:spPr>
+        <p:txBody>
+          <a:bodyPr wrap="none" rtlCol="0">
+            <a:spAutoFit/>
+          </a:bodyPr>
+          <a:lstStyle/>
+          <a:p>
+            <a:r>
+              <a:rPr lang="de-DE" sz="3200" b="1" dirty="0">
+                <a:solidFill>
+                  <a:srgbClr val="FF0000"/>
+                </a:solidFill>
+              </a:rPr>
+              <a:t>top_Arduino_nano_600mil_flex2</a:t>
+            </a:r>
+          </a:p>
+        </p:txBody>
+      </p:sp>
+      <p:sp>
+        <p:nvSpPr>
+          <p:cNvPr id="11" name="Textfeld 10">
+            <a:extLst>
+              <a:ext uri="{FF2B5EF4-FFF2-40B4-BE49-F238E27FC236}">
+                <a16:creationId xmlns:a16="http://schemas.microsoft.com/office/drawing/2014/main" id="{D5D549A9-03EC-FCD0-B795-4658180266B0}"/>
+              </a:ext>
+            </a:extLst>
+          </p:cNvPr>
+          <p:cNvSpPr txBox="1"/>
+          <p:nvPr/>
+        </p:nvSpPr>
+        <p:spPr>
+          <a:xfrm>
+            <a:off x="304449" y="5415404"/>
+            <a:ext cx="11362423" cy="1077218"/>
+          </a:xfrm>
+          <a:prstGeom prst="rect">
+            <a:avLst/>
+          </a:prstGeom>
+          <a:noFill/>
+        </p:spPr>
+        <p:txBody>
+          <a:bodyPr wrap="square" rtlCol="0">
+            <a:spAutoFit/>
+          </a:bodyPr>
+          <a:lstStyle/>
+          <a:p>
+            <a:pPr algn="ctr"/>
+            <a:r>
+              <a:rPr lang="de-DE" sz="3200" b="1" u="sng" dirty="0" err="1">
+                <a:solidFill>
+                  <a:srgbClr val="FF0000"/>
+                </a:solidFill>
+              </a:rPr>
+              <a:t>please</a:t>
+            </a:r>
+            <a:r>
+              <a:rPr lang="de-DE" sz="3200" b="1" u="sng" dirty="0">
+                <a:solidFill>
+                  <a:srgbClr val="FF0000"/>
+                </a:solidFill>
+              </a:rPr>
+              <a:t> </a:t>
+            </a:r>
+            <a:r>
+              <a:rPr lang="de-DE" sz="3200" b="1" u="sng" dirty="0" err="1">
+                <a:solidFill>
+                  <a:srgbClr val="FF0000"/>
+                </a:solidFill>
+              </a:rPr>
+              <a:t>note</a:t>
+            </a:r>
+            <a:r>
+              <a:rPr lang="de-DE" sz="3200" b="1" u="sng" dirty="0">
+                <a:solidFill>
+                  <a:srgbClr val="FF0000"/>
+                </a:solidFill>
+              </a:rPr>
+              <a:t>: </a:t>
+            </a:r>
+            <a:r>
+              <a:rPr lang="de-DE" sz="3200" b="1" dirty="0">
+                <a:solidFill>
+                  <a:srgbClr val="FF0000"/>
+                </a:solidFill>
+              </a:rPr>
+              <a:t>This </a:t>
+            </a:r>
+            <a:r>
+              <a:rPr lang="de-DE" sz="3200" b="1" dirty="0" err="1">
+                <a:solidFill>
+                  <a:srgbClr val="FF0000"/>
+                </a:solidFill>
+              </a:rPr>
+              <a:t>breadboard</a:t>
+            </a:r>
+            <a:r>
+              <a:rPr lang="de-DE" sz="3200" b="1" dirty="0">
+                <a:solidFill>
+                  <a:srgbClr val="FF0000"/>
+                </a:solidFill>
+              </a:rPr>
+              <a:t> </a:t>
+            </a:r>
+            <a:r>
+              <a:rPr lang="de-DE" sz="3200" b="1" dirty="0" err="1">
+                <a:solidFill>
+                  <a:srgbClr val="FF0000"/>
+                </a:solidFill>
+              </a:rPr>
+              <a:t>fits</a:t>
+            </a:r>
+            <a:r>
+              <a:rPr lang="de-DE" sz="3200" b="1" dirty="0">
+                <a:solidFill>
+                  <a:srgbClr val="FF0000"/>
+                </a:solidFill>
+              </a:rPr>
+              <a:t> </a:t>
+            </a:r>
+            <a:r>
+              <a:rPr lang="de-DE" sz="3200" b="1" dirty="0" err="1">
+                <a:solidFill>
+                  <a:srgbClr val="FF0000"/>
+                </a:solidFill>
+              </a:rPr>
+              <a:t>the</a:t>
+            </a:r>
+            <a:r>
+              <a:rPr lang="de-DE" sz="3200" b="1" dirty="0">
+                <a:solidFill>
+                  <a:srgbClr val="FF0000"/>
+                </a:solidFill>
+              </a:rPr>
+              <a:t> Arduino </a:t>
+            </a:r>
+            <a:r>
+              <a:rPr lang="de-DE" sz="3200" b="1" dirty="0" err="1">
+                <a:solidFill>
+                  <a:srgbClr val="FF0000"/>
+                </a:solidFill>
+              </a:rPr>
+              <a:t>nano</a:t>
+            </a:r>
+            <a:br>
+              <a:rPr lang="de-DE" sz="3200" b="1" dirty="0">
+                <a:solidFill>
+                  <a:srgbClr val="FF0000"/>
+                </a:solidFill>
+              </a:rPr>
+            </a:br>
+            <a:r>
+              <a:rPr lang="de-DE" sz="3200" b="1" dirty="0">
+                <a:solidFill>
+                  <a:srgbClr val="FF0000"/>
+                </a:solidFill>
+              </a:rPr>
+              <a:t>(</a:t>
+            </a:r>
+            <a:r>
+              <a:rPr lang="de-DE" sz="3200" b="1" dirty="0" err="1">
+                <a:solidFill>
+                  <a:srgbClr val="FF0000"/>
+                </a:solidFill>
+              </a:rPr>
+              <a:t>width</a:t>
+            </a:r>
+            <a:r>
+              <a:rPr lang="de-DE" sz="3200" b="1" dirty="0">
+                <a:solidFill>
+                  <a:srgbClr val="FF0000"/>
+                </a:solidFill>
+              </a:rPr>
+              <a:t>: 15.24 mm = 600 </a:t>
+            </a:r>
+            <a:r>
+              <a:rPr lang="de-DE" sz="3200" b="1" dirty="0" err="1">
+                <a:solidFill>
+                  <a:srgbClr val="FF0000"/>
+                </a:solidFill>
+              </a:rPr>
+              <a:t>mil</a:t>
+            </a:r>
+            <a:r>
+              <a:rPr lang="de-DE" sz="3200" b="1" dirty="0">
+                <a:solidFill>
+                  <a:srgbClr val="FF0000"/>
+                </a:solidFill>
+              </a:rPr>
+              <a:t>). </a:t>
+            </a:r>
+          </a:p>
+        </p:txBody>
+      </p:sp>
+    </p:spTree>
+    <p:extLst>
+      <p:ext uri="{BB962C8B-B14F-4D97-AF65-F5344CB8AC3E}">
+        <p14:creationId xmlns:p14="http://schemas.microsoft.com/office/powerpoint/2010/main" val="3481903796"/>
+      </p:ext>
+    </p:extLst>
+  </p:cSld>
+  <p:clrMapOvr>
+    <a:masterClrMapping/>
+  </p:clrMapOvr>
+</p:sld>
+</file>
+
 <file path=ppt/theme/theme1.xml><?xml version="1.0" encoding="utf-8"?>
 <a:theme xmlns:a="http://schemas.openxmlformats.org/drawingml/2006/main" name="Office">
   <a:themeElements>

</xml_diff>